<commit_message>
Replace 'The Creative' section with 'The Activation' media plan
Swap the left-column creative pillars for the paid-media activation:
AW360 (Run-of-Site, video pre-roll at sessions) and ADWEEK (Run-of-Site,
high-impact home page), each with placement detail and a benefit line.

Co-Authored-By: Claude Opus 4.8 <noreply@anthropic.com>
Claude-Session: https://claude.ai/code/session_01HmgFfyrGPiZxWXtNDQQB9Y
</commit_message>
<xml_diff>
--- a/Adstra_Advertising_Week_Video.pptx
+++ b/Adstra_Advertising_Week_Video.pptx
@@ -1046,7 +1046,7 @@
                 <a:ea typeface="Calibri" pitchFamily="34" charset="-122"/>
                 <a:cs typeface="Calibri" pitchFamily="34" charset="-120"/>
               </a:rPr>
-              <a:t>THE CREATIVE</a:t>
+              <a:t>THE ACTIVATION</a:t>
             </a:r>
             <a:endParaRPr lang="en-US" sz="1300" dirty="0"/>
           </a:p>
@@ -1099,8 +1099,8 @@
         </p:nvSpPr>
         <p:spPr>
           <a:xfrm>
-            <a:off x="566928" y="2505456"/>
-            <a:ext cx="493776" cy="493776"/>
+            <a:off x="566928" y="2871216"/>
+            <a:ext cx="603504" cy="603504"/>
           </a:xfrm>
           <a:prstGeom prst="ellipse">
             <a:avLst/>
@@ -1118,7 +1118,7 @@
       </p:sp>
       <p:pic>
         <p:nvPicPr>
-          <p:cNvPr id="8" name="Image 0" descr="ic_ny.png">    </p:cNvPr>
+          <p:cNvPr id="8" name="Image 0" descr="ic_aw360.png">    </p:cNvPr>
           <p:cNvPicPr>
             <a:picLocks noChangeAspect="1"/>
           </p:cNvPicPr>
@@ -1132,8 +1132,8 @@
         </p:blipFill>
         <p:spPr>
           <a:xfrm>
-            <a:off x="690372" y="2628900"/>
-            <a:ext cx="246888" cy="246888"/>
+            <a:off x="722376" y="3026664"/>
+            <a:ext cx="292608" cy="292608"/>
           </a:xfrm>
           <a:prstGeom prst="rect">
             <a:avLst/>
@@ -1148,8 +1148,8 @@
         </p:nvSpPr>
         <p:spPr>
           <a:xfrm>
-            <a:off x="1234440" y="2359152"/>
-            <a:ext cx="4434840" cy="786384"/>
+            <a:off x="1371600" y="2487168"/>
+            <a:ext cx="4297680" cy="1371600"/>
           </a:xfrm>
           <a:prstGeom prst="rect">
             <a:avLst/>
@@ -1163,12 +1163,15 @@
           <a:p>
             <a:pPr algn="l" indent="0" marL="0">
               <a:lnSpc>
-                <a:spcPct val="98000"/>
+                <a:spcPct val="102000"/>
               </a:lnSpc>
-              <a:buNone/>
-            </a:pPr>
-            <a:r>
-              <a:rPr lang="en-US" sz="1500" b="1" dirty="0">
+              <a:spcAft>
+                <a:spcPts val="300"/>
+              </a:spcAft>
+              <a:buNone/>
+            </a:pPr>
+            <a:r>
+              <a:rPr lang="en-US" sz="1900" b="1" dirty="0">
                 <a:solidFill>
                   <a:srgbClr val="FFFFFF"/>
                 </a:solidFill>
@@ -1176,29 +1179,55 @@
                 <a:ea typeface="Calibri" pitchFamily="34" charset="-122"/>
                 <a:cs typeface="Calibri" pitchFamily="34" charset="-120"/>
               </a:rPr>
-              <a:t>A New York story, not a tagline</a:t>
-            </a:r>
-            <a:endParaRPr lang="en-US" sz="1500" dirty="0"/>
+              <a:t>AW360</a:t>
+            </a:r>
+            <a:endParaRPr lang="en-US" sz="1900" dirty="0"/>
           </a:p>
           <a:p>
             <a:pPr algn="l" indent="0" marL="0">
               <a:lnSpc>
-                <a:spcPct val="98000"/>
+                <a:spcPct val="102000"/>
               </a:lnSpc>
-              <a:buNone/>
-            </a:pPr>
-            <a:r>
-              <a:rPr lang="en-US" sz="1150" dirty="0">
-                <a:solidFill>
-                  <a:srgbClr val="C9BCE8"/>
+              <a:spcAft>
+                <a:spcPts val="300"/>
+              </a:spcAft>
+              <a:buNone/>
+            </a:pPr>
+            <a:r>
+              <a:rPr lang="en-US" sz="1250" b="1" dirty="0">
+                <a:solidFill>
+                  <a:srgbClr val="8B5CF6"/>
                 </a:solidFill>
                 <a:latin typeface="Calibri" pitchFamily="34" charset="0"/>
                 <a:ea typeface="Calibri" pitchFamily="34" charset="-122"/>
                 <a:cs typeface="Calibri" pitchFamily="34" charset="-120"/>
               </a:rPr>
-              <a:t>Subway doors, taxis, Times Square, neon — a day-to-night arc through the city. Ownable, not borrowed.</a:t>
-            </a:r>
-            <a:endParaRPr lang="en-US" sz="1500" dirty="0"/>
+              <a:t>Run-of-Site  ·  Video pre-roll at sessions</a:t>
+            </a:r>
+            <a:endParaRPr lang="en-US" sz="1900" dirty="0"/>
+          </a:p>
+          <a:p>
+            <a:pPr algn="l" indent="0" marL="0">
+              <a:lnSpc>
+                <a:spcPct val="102000"/>
+              </a:lnSpc>
+              <a:spcAft>
+                <a:spcPts val="300"/>
+              </a:spcAft>
+              <a:buNone/>
+            </a:pPr>
+            <a:r>
+              <a:rPr lang="en-US" sz="1150" dirty="0">
+                <a:solidFill>
+                  <a:srgbClr val="C9BCE8"/>
+                </a:solidFill>
+                <a:latin typeface="Calibri" pitchFamily="34" charset="0"/>
+                <a:ea typeface="Calibri" pitchFamily="34" charset="-122"/>
+                <a:cs typeface="Calibri" pitchFamily="34" charset="-120"/>
+              </a:rPr>
+              <a:t>The :30 and :15 run as pre-roll across AdvertisingWeek360 session video — reaching marketers mid-session, in context.</a:t>
+            </a:r>
+            <a:endParaRPr lang="en-US" sz="1900" dirty="0"/>
           </a:p>
         </p:txBody>
       </p:sp>
@@ -1210,8 +1239,8 @@
         </p:nvSpPr>
         <p:spPr>
           <a:xfrm>
-            <a:off x="566928" y="3319272"/>
-            <a:ext cx="493776" cy="493776"/>
+            <a:off x="566928" y="4443984"/>
+            <a:ext cx="603504" cy="603504"/>
           </a:xfrm>
           <a:prstGeom prst="ellipse">
             <a:avLst/>
@@ -1229,7 +1258,7 @@
       </p:sp>
       <p:pic>
         <p:nvPicPr>
-          <p:cNvPr id="11" name="Image 1" descr="ic_color.png">    </p:cNvPr>
+          <p:cNvPr id="11" name="Image 1" descr="ic_adweek.png">    </p:cNvPr>
           <p:cNvPicPr>
             <a:picLocks noChangeAspect="1"/>
           </p:cNvPicPr>
@@ -1243,8 +1272,8 @@
         </p:blipFill>
         <p:spPr>
           <a:xfrm>
-            <a:off x="690372" y="3442716"/>
-            <a:ext cx="246888" cy="246888"/>
+            <a:off x="722376" y="4599432"/>
+            <a:ext cx="292608" cy="292608"/>
           </a:xfrm>
           <a:prstGeom prst="rect">
             <a:avLst/>
@@ -1259,8 +1288,8 @@
         </p:nvSpPr>
         <p:spPr>
           <a:xfrm>
-            <a:off x="1234440" y="3172968"/>
-            <a:ext cx="4434840" cy="786384"/>
+            <a:off x="1371600" y="4059936"/>
+            <a:ext cx="4297680" cy="1371600"/>
           </a:xfrm>
           <a:prstGeom prst="rect">
             <a:avLst/>
@@ -1274,12 +1303,15 @@
           <a:p>
             <a:pPr algn="l" indent="0" marL="0">
               <a:lnSpc>
-                <a:spcPct val="98000"/>
+                <a:spcPct val="102000"/>
               </a:lnSpc>
-              <a:buNone/>
-            </a:pPr>
-            <a:r>
-              <a:rPr lang="en-US" sz="1500" b="1" dirty="0">
+              <a:spcAft>
+                <a:spcPts val="300"/>
+              </a:spcAft>
+              <a:buNone/>
+            </a:pPr>
+            <a:r>
+              <a:rPr lang="en-US" sz="1900" b="1" dirty="0">
                 <a:solidFill>
                   <a:srgbClr val="FFFFFF"/>
                 </a:solidFill>
@@ -1287,257 +1319,61 @@
                 <a:ea typeface="Calibri" pitchFamily="34" charset="-122"/>
                 <a:cs typeface="Calibri" pitchFamily="34" charset="-120"/>
               </a:rPr>
-              <a:t>Brand purple, felt not forced</a:t>
-            </a:r>
-            <a:endParaRPr lang="en-US" sz="1500" dirty="0"/>
+              <a:t>ADWEEK</a:t>
+            </a:r>
+            <a:endParaRPr lang="en-US" sz="1900" dirty="0"/>
           </a:p>
           <a:p>
             <a:pPr algn="l" indent="0" marL="0">
               <a:lnSpc>
-                <a:spcPct val="98000"/>
+                <a:spcPct val="102000"/>
               </a:lnSpc>
-              <a:buNone/>
-            </a:pPr>
-            <a:r>
-              <a:rPr lang="en-US" sz="1150" dirty="0">
-                <a:solidFill>
-                  <a:srgbClr val="C9BCE8"/>
+              <a:spcAft>
+                <a:spcPts val="300"/>
+              </a:spcAft>
+              <a:buNone/>
+            </a:pPr>
+            <a:r>
+              <a:rPr lang="en-US" sz="1250" b="1" dirty="0">
+                <a:solidFill>
+                  <a:srgbClr val="8B5CF6"/>
                 </a:solidFill>
                 <a:latin typeface="Calibri" pitchFamily="34" charset="0"/>
                 <a:ea typeface="Calibri" pitchFamily="34" charset="-122"/>
                 <a:cs typeface="Calibri" pitchFamily="34" charset="-120"/>
               </a:rPr>
-              <a:t>A light color grade nods to Adstra purple in every frame — present throughout, never purple-washed.</a:t>
-            </a:r>
-            <a:endParaRPr lang="en-US" sz="1500" dirty="0"/>
-          </a:p>
-        </p:txBody>
-      </p:sp>
-      <p:sp>
-        <p:nvSpPr>
-          <p:cNvPr id="13" name="Shape 9"/>
-          <p:cNvSpPr/>
-          <p:nvPr/>
-        </p:nvSpPr>
-        <p:spPr>
-          <a:xfrm>
-            <a:off x="566928" y="4133088"/>
-            <a:ext cx="493776" cy="493776"/>
-          </a:xfrm>
-          <a:prstGeom prst="ellipse">
-            <a:avLst/>
-          </a:prstGeom>
-          <a:solidFill>
-            <a:srgbClr val="6D28D9"/>
-          </a:solidFill>
-          <a:ln w="12700">
-            <a:solidFill>
-              <a:srgbClr val="8B5CF6"/>
-            </a:solidFill>
-            <a:prstDash val="solid"/>
-          </a:ln>
-        </p:spPr>
-      </p:sp>
-      <p:pic>
-        <p:nvPicPr>
-          <p:cNvPr id="14" name="Image 2" descr="ic_scene.png">    </p:cNvPr>
-          <p:cNvPicPr>
-            <a:picLocks noChangeAspect="1"/>
-          </p:cNvPicPr>
-          <p:nvPr/>
-        </p:nvPicPr>
-        <p:blipFill>
-          <a:blip r:embed="rId4"/>
-          <a:stretch>
-            <a:fillRect/>
-          </a:stretch>
-        </p:blipFill>
-        <p:spPr>
-          <a:xfrm>
-            <a:off x="690372" y="4256532"/>
-            <a:ext cx="246888" cy="246888"/>
-          </a:xfrm>
-          <a:prstGeom prst="rect">
-            <a:avLst/>
-          </a:prstGeom>
-        </p:spPr>
-      </p:pic>
-      <p:sp>
-        <p:nvSpPr>
-          <p:cNvPr id="15" name="Text 10"/>
-          <p:cNvSpPr/>
-          <p:nvPr/>
-        </p:nvSpPr>
-        <p:spPr>
-          <a:xfrm>
-            <a:off x="1234440" y="3986784"/>
-            <a:ext cx="4434840" cy="786384"/>
-          </a:xfrm>
-          <a:prstGeom prst="rect">
-            <a:avLst/>
-          </a:prstGeom>
-          <a:noFill/>
-          <a:ln/>
-        </p:spPr>
-        <p:txBody>
-          <a:bodyPr wrap="square" lIns="0" tIns="0" rIns="0" bIns="0" rtlCol="0" anchor="ctr"/>
-          <a:lstStyle/>
+              <a:t>Run-of-Site  ·  High-impact Home Page</a:t>
+            </a:r>
+            <a:endParaRPr lang="en-US" sz="1900" dirty="0"/>
+          </a:p>
           <a:p>
             <a:pPr algn="l" indent="0" marL="0">
               <a:lnSpc>
-                <a:spcPct val="98000"/>
+                <a:spcPct val="102000"/>
               </a:lnSpc>
-              <a:buNone/>
-            </a:pPr>
-            <a:r>
-              <a:rPr lang="en-US" sz="1500" b="1" dirty="0">
-                <a:solidFill>
-                  <a:srgbClr val="FFFFFF"/>
+              <a:spcAft>
+                <a:spcPts val="300"/>
+              </a:spcAft>
+              <a:buNone/>
+            </a:pPr>
+            <a:r>
+              <a:rPr lang="en-US" sz="1150" dirty="0">
+                <a:solidFill>
+                  <a:srgbClr val="C9BCE8"/>
                 </a:solidFill>
                 <a:latin typeface="Calibri" pitchFamily="34" charset="0"/>
                 <a:ea typeface="Calibri" pitchFamily="34" charset="-122"/>
                 <a:cs typeface="Calibri" pitchFamily="34" charset="-120"/>
               </a:rPr>
-              <a:t>Messaging built into the scene</a:t>
-            </a:r>
-            <a:endParaRPr lang="en-US" sz="1500" dirty="0"/>
-          </a:p>
-          <a:p>
-            <a:pPr algn="l" indent="0" marL="0">
-              <a:lnSpc>
-                <a:spcPct val="98000"/>
-              </a:lnSpc>
-              <a:buNone/>
-            </a:pPr>
-            <a:r>
-              <a:rPr lang="en-US" sz="1150" dirty="0">
-                <a:solidFill>
-                  <a:srgbClr val="C9BCE8"/>
-                </a:solidFill>
-                <a:latin typeface="Calibri" pitchFamily="34" charset="0"/>
-                <a:ea typeface="Calibri" pitchFamily="34" charset="-122"/>
-                <a:cs typeface="Calibri" pitchFamily="34" charset="-120"/>
-              </a:rPr>
-              <a:t>Brand woven into subway signage and taxi ad space — native to the footage, not text layered on top.</a:t>
-            </a:r>
-            <a:endParaRPr lang="en-US" sz="1500" dirty="0"/>
+              <a:t>A high-impact homepage unit on Adweek.com keeps Adstra front-and-center site-wide through the event week.</a:t>
+            </a:r>
+            <a:endParaRPr lang="en-US" sz="1900" dirty="0"/>
           </a:p>
         </p:txBody>
       </p:sp>
       <p:sp>
         <p:nvSpPr>
-          <p:cNvPr id="16" name="Shape 11"/>
-          <p:cNvSpPr/>
-          <p:nvPr/>
-        </p:nvSpPr>
-        <p:spPr>
-          <a:xfrm>
-            <a:off x="566928" y="4946904"/>
-            <a:ext cx="493776" cy="493776"/>
-          </a:xfrm>
-          <a:prstGeom prst="ellipse">
-            <a:avLst/>
-          </a:prstGeom>
-          <a:solidFill>
-            <a:srgbClr val="6D28D9"/>
-          </a:solidFill>
-          <a:ln w="12700">
-            <a:solidFill>
-              <a:srgbClr val="8B5CF6"/>
-            </a:solidFill>
-            <a:prstDash val="solid"/>
-          </a:ln>
-        </p:spPr>
-      </p:sp>
-      <p:pic>
-        <p:nvPicPr>
-          <p:cNvPr id="17" name="Image 3" descr="ic_logo.png">    </p:cNvPr>
-          <p:cNvPicPr>
-            <a:picLocks noChangeAspect="1"/>
-          </p:cNvPicPr>
-          <p:nvPr/>
-        </p:nvPicPr>
-        <p:blipFill>
-          <a:blip r:embed="rId5"/>
-          <a:stretch>
-            <a:fillRect/>
-          </a:stretch>
-        </p:blipFill>
-        <p:spPr>
-          <a:xfrm>
-            <a:off x="690372" y="5070348"/>
-            <a:ext cx="246888" cy="246888"/>
-          </a:xfrm>
-          <a:prstGeom prst="rect">
-            <a:avLst/>
-          </a:prstGeom>
-        </p:spPr>
-      </p:pic>
-      <p:sp>
-        <p:nvSpPr>
-          <p:cNvPr id="18" name="Text 12"/>
-          <p:cNvSpPr/>
-          <p:nvPr/>
-        </p:nvSpPr>
-        <p:spPr>
-          <a:xfrm>
-            <a:off x="1234440" y="4800600"/>
-            <a:ext cx="4434840" cy="786384"/>
-          </a:xfrm>
-          <a:prstGeom prst="rect">
-            <a:avLst/>
-          </a:prstGeom>
-          <a:noFill/>
-          <a:ln/>
-        </p:spPr>
-        <p:txBody>
-          <a:bodyPr wrap="square" lIns="0" tIns="0" rIns="0" bIns="0" rtlCol="0" anchor="ctr"/>
-          <a:lstStyle/>
-          <a:p>
-            <a:pPr algn="l" indent="0" marL="0">
-              <a:lnSpc>
-                <a:spcPct val="98000"/>
-              </a:lnSpc>
-              <a:buNone/>
-            </a:pPr>
-            <a:r>
-              <a:rPr lang="en-US" sz="1500" b="1" dirty="0">
-                <a:solidFill>
-                  <a:srgbClr val="FFFFFF"/>
-                </a:solidFill>
-                <a:latin typeface="Calibri" pitchFamily="34" charset="0"/>
-                <a:ea typeface="Calibri" pitchFamily="34" charset="-122"/>
-                <a:cs typeface="Calibri" pitchFamily="34" charset="-120"/>
-              </a:rPr>
-              <a:t>A polished logo animation</a:t>
-            </a:r>
-            <a:endParaRPr lang="en-US" sz="1500" dirty="0"/>
-          </a:p>
-          <a:p>
-            <a:pPr algn="l" indent="0" marL="0">
-              <a:lnSpc>
-                <a:spcPct val="98000"/>
-              </a:lnSpc>
-              <a:buNone/>
-            </a:pPr>
-            <a:r>
-              <a:rPr lang="en-US" sz="1150" dirty="0">
-                <a:solidFill>
-                  <a:srgbClr val="C9BCE8"/>
-                </a:solidFill>
-                <a:latin typeface="Calibri" pitchFamily="34" charset="0"/>
-                <a:ea typeface="Calibri" pitchFamily="34" charset="-122"/>
-                <a:cs typeface="Calibri" pitchFamily="34" charset="-120"/>
-              </a:rPr>
-              <a:t>The one place for true custom animation — a clean, reusable Adstra lockup that plugs into whatever comes next.</a:t>
-            </a:r>
-            <a:endParaRPr lang="en-US" sz="1500" dirty="0"/>
-          </a:p>
-        </p:txBody>
-      </p:sp>
-      <p:sp>
-        <p:nvSpPr>
-          <p:cNvPr id="19" name="Shape 13"/>
+          <p:cNvPr id="13" name="Shape 9"/>
           <p:cNvSpPr/>
           <p:nvPr/>
         </p:nvSpPr>
@@ -1560,7 +1396,7 @@
       </p:sp>
       <p:sp>
         <p:nvSpPr>
-          <p:cNvPr id="20" name="Shape 14"/>
+          <p:cNvPr id="14" name="Shape 10"/>
           <p:cNvSpPr/>
           <p:nvPr/>
         </p:nvSpPr>
@@ -1594,7 +1430,7 @@
       </p:sp>
       <p:sp>
         <p:nvSpPr>
-          <p:cNvPr id="21" name="Text 15"/>
+          <p:cNvPr id="15" name="Text 11"/>
           <p:cNvSpPr/>
           <p:nvPr/>
         </p:nvSpPr>
@@ -1647,7 +1483,7 @@
       </p:sp>
       <p:sp>
         <p:nvSpPr>
-          <p:cNvPr id="22" name="Text 16"/>
+          <p:cNvPr id="16" name="Text 12"/>
           <p:cNvSpPr/>
           <p:nvPr/>
         </p:nvSpPr>
@@ -1709,7 +1545,7 @@
       </p:sp>
       <p:sp>
         <p:nvSpPr>
-          <p:cNvPr id="23" name="Shape 17"/>
+          <p:cNvPr id="17" name="Shape 13"/>
           <p:cNvSpPr/>
           <p:nvPr/>
         </p:nvSpPr>
@@ -1743,7 +1579,7 @@
       </p:sp>
       <p:sp>
         <p:nvSpPr>
-          <p:cNvPr id="24" name="Text 18"/>
+          <p:cNvPr id="18" name="Text 14"/>
           <p:cNvSpPr/>
           <p:nvPr/>
         </p:nvSpPr>
@@ -1796,7 +1632,7 @@
       </p:sp>
       <p:sp>
         <p:nvSpPr>
-          <p:cNvPr id="25" name="Text 19"/>
+          <p:cNvPr id="19" name="Text 15"/>
           <p:cNvSpPr/>
           <p:nvPr/>
         </p:nvSpPr>
@@ -1858,7 +1694,7 @@
       </p:sp>
       <p:sp>
         <p:nvSpPr>
-          <p:cNvPr id="26" name="Shape 20"/>
+          <p:cNvPr id="20" name="Shape 16"/>
           <p:cNvSpPr/>
           <p:nvPr/>
         </p:nvSpPr>
@@ -1892,7 +1728,7 @@
       </p:sp>
       <p:sp>
         <p:nvSpPr>
-          <p:cNvPr id="27" name="Text 21"/>
+          <p:cNvPr id="21" name="Text 17"/>
           <p:cNvSpPr/>
           <p:nvPr/>
         </p:nvSpPr>
@@ -1945,7 +1781,7 @@
       </p:sp>
       <p:sp>
         <p:nvSpPr>
-          <p:cNvPr id="28" name="Text 22"/>
+          <p:cNvPr id="22" name="Text 18"/>
           <p:cNvSpPr/>
           <p:nvPr/>
         </p:nvSpPr>
@@ -2007,7 +1843,7 @@
       </p:sp>
       <p:sp>
         <p:nvSpPr>
-          <p:cNvPr id="29" name="Shape 23"/>
+          <p:cNvPr id="23" name="Shape 19"/>
           <p:cNvSpPr/>
           <p:nvPr/>
         </p:nvSpPr>
@@ -2041,7 +1877,7 @@
       </p:sp>
       <p:sp>
         <p:nvSpPr>
-          <p:cNvPr id="30" name="Text 24"/>
+          <p:cNvPr id="24" name="Text 20"/>
           <p:cNvSpPr/>
           <p:nvPr/>
         </p:nvSpPr>
@@ -2094,7 +1930,7 @@
       </p:sp>
       <p:sp>
         <p:nvSpPr>
-          <p:cNvPr id="31" name="Text 25"/>
+          <p:cNvPr id="25" name="Text 21"/>
           <p:cNvSpPr/>
           <p:nvPr/>
         </p:nvSpPr>
@@ -2156,7 +1992,7 @@
       </p:sp>
       <p:sp>
         <p:nvSpPr>
-          <p:cNvPr id="32" name="Shape 26"/>
+          <p:cNvPr id="26" name="Shape 22"/>
           <p:cNvSpPr/>
           <p:nvPr/>
         </p:nvSpPr>
@@ -2183,7 +2019,7 @@
       </p:sp>
       <p:sp>
         <p:nvSpPr>
-          <p:cNvPr id="33" name="Text 27"/>
+          <p:cNvPr id="27" name="Text 23"/>
           <p:cNvSpPr/>
           <p:nvPr/>
         </p:nvSpPr>
@@ -2236,7 +2072,7 @@
       </p:sp>
       <p:sp>
         <p:nvSpPr>
-          <p:cNvPr id="34" name="Shape 28"/>
+          <p:cNvPr id="28" name="Shape 24"/>
           <p:cNvSpPr/>
           <p:nvPr/>
         </p:nvSpPr>
@@ -2259,7 +2095,7 @@
       </p:sp>
       <p:sp>
         <p:nvSpPr>
-          <p:cNvPr id="35" name="Text 29"/>
+          <p:cNvPr id="29" name="Text 25"/>
           <p:cNvSpPr/>
           <p:nvPr/>
         </p:nvSpPr>
@@ -2312,7 +2148,7 @@
       </p:sp>
       <p:sp>
         <p:nvSpPr>
-          <p:cNvPr id="36" name="Shape 30"/>
+          <p:cNvPr id="30" name="Shape 26"/>
           <p:cNvSpPr/>
           <p:nvPr/>
         </p:nvSpPr>
@@ -2335,7 +2171,7 @@
       </p:sp>
       <p:sp>
         <p:nvSpPr>
-          <p:cNvPr id="37" name="Text 31"/>
+          <p:cNvPr id="31" name="Text 27"/>
           <p:cNvSpPr/>
           <p:nvPr/>
         </p:nvSpPr>

</xml_diff>